<commit_message>
Add 2 more examples
</commit_message>
<xml_diff>
--- a/Signals in Angular.pptx
+++ b/Signals in Angular.pptx
@@ -4,6 +4,9 @@
   <p:sldMasterIdLst>
     <p:sldMasterId id="2147483660" r:id="rId1"/>
   </p:sldMasterIdLst>
+  <p:notesMasterIdLst>
+    <p:notesMasterId r:id="rId33"/>
+  </p:notesMasterIdLst>
   <p:sldIdLst>
     <p:sldId id="256" r:id="rId2"/>
     <p:sldId id="258" r:id="rId3"/>
@@ -134,7 +137,445 @@
       </a:defRPr>
     </a:lvl9pPr>
   </p:defaultTextStyle>
+  <p:extLst>
+    <p:ext uri="{EFAFB233-063F-42B5-8137-9DF3F51BA10A}">
+      <p15:sldGuideLst xmlns:p15="http://schemas.microsoft.com/office/powerpoint/2012/main"/>
+    </p:ext>
+  </p:extLst>
 </p:presentation>
+</file>
+
+<file path=ppt/notesMasters/notesMaster1.xml><?xml version="1.0" encoding="utf-8"?>
+<p:notesMaster xmlns:a="http://schemas.openxmlformats.org/drawingml/2006/main" xmlns:r="http://schemas.openxmlformats.org/officeDocument/2006/relationships" xmlns:p="http://schemas.openxmlformats.org/presentationml/2006/main">
+  <p:cSld>
+    <p:bg>
+      <p:bgRef idx="1001">
+        <a:schemeClr val="bg1"/>
+      </p:bgRef>
+    </p:bg>
+    <p:spTree>
+      <p:nvGrpSpPr>
+        <p:cNvPr id="1" name=""/>
+        <p:cNvGrpSpPr/>
+        <p:nvPr/>
+      </p:nvGrpSpPr>
+      <p:grpSpPr>
+        <a:xfrm>
+          <a:off x="0" y="0"/>
+          <a:ext cx="0" cy="0"/>
+          <a:chOff x="0" y="0"/>
+          <a:chExt cx="0" cy="0"/>
+        </a:xfrm>
+      </p:grpSpPr>
+      <p:sp>
+        <p:nvSpPr>
+          <p:cNvPr id="2" name="Header Placeholder 1"/>
+          <p:cNvSpPr>
+            <a:spLocks noGrp="1"/>
+          </p:cNvSpPr>
+          <p:nvPr>
+            <p:ph type="hdr" sz="quarter"/>
+          </p:nvPr>
+        </p:nvSpPr>
+        <p:spPr>
+          <a:xfrm>
+            <a:off x="0" y="0"/>
+            <a:ext cx="2971800" cy="458788"/>
+          </a:xfrm>
+          <a:prstGeom prst="rect">
+            <a:avLst/>
+          </a:prstGeom>
+        </p:spPr>
+        <p:txBody>
+          <a:bodyPr vert="horz" lIns="91440" tIns="45720" rIns="91440" bIns="45720" rtlCol="0"/>
+          <a:lstStyle>
+            <a:lvl1pPr algn="l">
+              <a:defRPr sz="1200"/>
+            </a:lvl1pPr>
+          </a:lstStyle>
+          <a:p>
+            <a:endParaRPr lang="en-US"/>
+          </a:p>
+        </p:txBody>
+      </p:sp>
+      <p:sp>
+        <p:nvSpPr>
+          <p:cNvPr id="3" name="Date Placeholder 2"/>
+          <p:cNvSpPr>
+            <a:spLocks noGrp="1"/>
+          </p:cNvSpPr>
+          <p:nvPr>
+            <p:ph type="dt" idx="1"/>
+          </p:nvPr>
+        </p:nvSpPr>
+        <p:spPr>
+          <a:xfrm>
+            <a:off x="3884613" y="0"/>
+            <a:ext cx="2971800" cy="458788"/>
+          </a:xfrm>
+          <a:prstGeom prst="rect">
+            <a:avLst/>
+          </a:prstGeom>
+        </p:spPr>
+        <p:txBody>
+          <a:bodyPr vert="horz" lIns="91440" tIns="45720" rIns="91440" bIns="45720" rtlCol="0"/>
+          <a:lstStyle>
+            <a:lvl1pPr algn="r">
+              <a:defRPr sz="1200"/>
+            </a:lvl1pPr>
+          </a:lstStyle>
+          <a:p>
+            <a:fld id="{6EE27784-C285-4B21-BA6B-B3499FBD7B11}" type="datetimeFigureOut">
+              <a:rPr lang="en-US" smtClean="0"/>
+              <a:t>3/23/2026</a:t>
+            </a:fld>
+            <a:endParaRPr lang="en-US"/>
+          </a:p>
+        </p:txBody>
+      </p:sp>
+      <p:sp>
+        <p:nvSpPr>
+          <p:cNvPr id="4" name="Slide Image Placeholder 3"/>
+          <p:cNvSpPr>
+            <a:spLocks noGrp="1" noRot="1" noChangeAspect="1"/>
+          </p:cNvSpPr>
+          <p:nvPr>
+            <p:ph type="sldImg" idx="2"/>
+          </p:nvPr>
+        </p:nvSpPr>
+        <p:spPr>
+          <a:xfrm>
+            <a:off x="685800" y="1143000"/>
+            <a:ext cx="5486400" cy="3086100"/>
+          </a:xfrm>
+          <a:prstGeom prst="rect">
+            <a:avLst/>
+          </a:prstGeom>
+          <a:noFill/>
+          <a:ln w="12700">
+            <a:solidFill>
+              <a:prstClr val="black"/>
+            </a:solidFill>
+          </a:ln>
+        </p:spPr>
+        <p:txBody>
+          <a:bodyPr vert="horz" lIns="91440" tIns="45720" rIns="91440" bIns="45720" rtlCol="0" anchor="ctr"/>
+          <a:lstStyle/>
+          <a:p>
+            <a:endParaRPr lang="en-US"/>
+          </a:p>
+        </p:txBody>
+      </p:sp>
+      <p:sp>
+        <p:nvSpPr>
+          <p:cNvPr id="5" name="Notes Placeholder 4"/>
+          <p:cNvSpPr>
+            <a:spLocks noGrp="1"/>
+          </p:cNvSpPr>
+          <p:nvPr>
+            <p:ph type="body" sz="quarter" idx="3"/>
+          </p:nvPr>
+        </p:nvSpPr>
+        <p:spPr>
+          <a:xfrm>
+            <a:off x="685800" y="4400550"/>
+            <a:ext cx="5486400" cy="3600450"/>
+          </a:xfrm>
+          <a:prstGeom prst="rect">
+            <a:avLst/>
+          </a:prstGeom>
+        </p:spPr>
+        <p:txBody>
+          <a:bodyPr vert="horz" lIns="91440" tIns="45720" rIns="91440" bIns="45720" rtlCol="0"/>
+          <a:lstStyle/>
+          <a:p>
+            <a:pPr lvl="0"/>
+            <a:r>
+              <a:rPr lang="en-US"/>
+              <a:t>Click to edit Master text styles</a:t>
+            </a:r>
+          </a:p>
+          <a:p>
+            <a:pPr lvl="1"/>
+            <a:r>
+              <a:rPr lang="en-US"/>
+              <a:t>Second level</a:t>
+            </a:r>
+          </a:p>
+          <a:p>
+            <a:pPr lvl="2"/>
+            <a:r>
+              <a:rPr lang="en-US"/>
+              <a:t>Third level</a:t>
+            </a:r>
+          </a:p>
+          <a:p>
+            <a:pPr lvl="3"/>
+            <a:r>
+              <a:rPr lang="en-US"/>
+              <a:t>Fourth level</a:t>
+            </a:r>
+          </a:p>
+          <a:p>
+            <a:pPr lvl="4"/>
+            <a:r>
+              <a:rPr lang="en-US"/>
+              <a:t>Fifth level</a:t>
+            </a:r>
+          </a:p>
+        </p:txBody>
+      </p:sp>
+      <p:sp>
+        <p:nvSpPr>
+          <p:cNvPr id="6" name="Footer Placeholder 5"/>
+          <p:cNvSpPr>
+            <a:spLocks noGrp="1"/>
+          </p:cNvSpPr>
+          <p:nvPr>
+            <p:ph type="ftr" sz="quarter" idx="4"/>
+          </p:nvPr>
+        </p:nvSpPr>
+        <p:spPr>
+          <a:xfrm>
+            <a:off x="0" y="8685213"/>
+            <a:ext cx="2971800" cy="458787"/>
+          </a:xfrm>
+          <a:prstGeom prst="rect">
+            <a:avLst/>
+          </a:prstGeom>
+        </p:spPr>
+        <p:txBody>
+          <a:bodyPr vert="horz" lIns="91440" tIns="45720" rIns="91440" bIns="45720" rtlCol="0" anchor="b"/>
+          <a:lstStyle>
+            <a:lvl1pPr algn="l">
+              <a:defRPr sz="1200"/>
+            </a:lvl1pPr>
+          </a:lstStyle>
+          <a:p>
+            <a:endParaRPr lang="en-US"/>
+          </a:p>
+        </p:txBody>
+      </p:sp>
+      <p:sp>
+        <p:nvSpPr>
+          <p:cNvPr id="7" name="Slide Number Placeholder 6"/>
+          <p:cNvSpPr>
+            <a:spLocks noGrp="1"/>
+          </p:cNvSpPr>
+          <p:nvPr>
+            <p:ph type="sldNum" sz="quarter" idx="5"/>
+          </p:nvPr>
+        </p:nvSpPr>
+        <p:spPr>
+          <a:xfrm>
+            <a:off x="3884613" y="8685213"/>
+            <a:ext cx="2971800" cy="458787"/>
+          </a:xfrm>
+          <a:prstGeom prst="rect">
+            <a:avLst/>
+          </a:prstGeom>
+        </p:spPr>
+        <p:txBody>
+          <a:bodyPr vert="horz" lIns="91440" tIns="45720" rIns="91440" bIns="45720" rtlCol="0" anchor="b"/>
+          <a:lstStyle>
+            <a:lvl1pPr algn="r">
+              <a:defRPr sz="1200"/>
+            </a:lvl1pPr>
+          </a:lstStyle>
+          <a:p>
+            <a:fld id="{1E3DBBED-931B-4EE7-9616-2DA9C22A96FE}" type="slidenum">
+              <a:rPr lang="en-US" smtClean="0"/>
+              <a:t>‹#›</a:t>
+            </a:fld>
+            <a:endParaRPr lang="en-US"/>
+          </a:p>
+        </p:txBody>
+      </p:sp>
+    </p:spTree>
+    <p:extLst>
+      <p:ext uri="{BB962C8B-B14F-4D97-AF65-F5344CB8AC3E}">
+        <p14:creationId xmlns:p14="http://schemas.microsoft.com/office/powerpoint/2010/main" val="3487530060"/>
+      </p:ext>
+    </p:extLst>
+  </p:cSld>
+  <p:clrMap bg1="lt1" tx1="dk1" bg2="lt2" tx2="dk2" accent1="accent1" accent2="accent2" accent3="accent3" accent4="accent4" accent5="accent5" accent6="accent6" hlink="hlink" folHlink="folHlink"/>
+  <p:notesStyle>
+    <a:lvl1pPr marL="0" algn="l" defTabSz="914400" rtl="0" eaLnBrk="1" latinLnBrk="0" hangingPunct="1">
+      <a:defRPr sz="1200" kern="1200">
+        <a:solidFill>
+          <a:schemeClr val="tx1"/>
+        </a:solidFill>
+        <a:latin typeface="+mn-lt"/>
+        <a:ea typeface="+mn-ea"/>
+        <a:cs typeface="+mn-cs"/>
+      </a:defRPr>
+    </a:lvl1pPr>
+    <a:lvl2pPr marL="457200" algn="l" defTabSz="914400" rtl="0" eaLnBrk="1" latinLnBrk="0" hangingPunct="1">
+      <a:defRPr sz="1200" kern="1200">
+        <a:solidFill>
+          <a:schemeClr val="tx1"/>
+        </a:solidFill>
+        <a:latin typeface="+mn-lt"/>
+        <a:ea typeface="+mn-ea"/>
+        <a:cs typeface="+mn-cs"/>
+      </a:defRPr>
+    </a:lvl2pPr>
+    <a:lvl3pPr marL="914400" algn="l" defTabSz="914400" rtl="0" eaLnBrk="1" latinLnBrk="0" hangingPunct="1">
+      <a:defRPr sz="1200" kern="1200">
+        <a:solidFill>
+          <a:schemeClr val="tx1"/>
+        </a:solidFill>
+        <a:latin typeface="+mn-lt"/>
+        <a:ea typeface="+mn-ea"/>
+        <a:cs typeface="+mn-cs"/>
+      </a:defRPr>
+    </a:lvl3pPr>
+    <a:lvl4pPr marL="1371600" algn="l" defTabSz="914400" rtl="0" eaLnBrk="1" latinLnBrk="0" hangingPunct="1">
+      <a:defRPr sz="1200" kern="1200">
+        <a:solidFill>
+          <a:schemeClr val="tx1"/>
+        </a:solidFill>
+        <a:latin typeface="+mn-lt"/>
+        <a:ea typeface="+mn-ea"/>
+        <a:cs typeface="+mn-cs"/>
+      </a:defRPr>
+    </a:lvl4pPr>
+    <a:lvl5pPr marL="1828800" algn="l" defTabSz="914400" rtl="0" eaLnBrk="1" latinLnBrk="0" hangingPunct="1">
+      <a:defRPr sz="1200" kern="1200">
+        <a:solidFill>
+          <a:schemeClr val="tx1"/>
+        </a:solidFill>
+        <a:latin typeface="+mn-lt"/>
+        <a:ea typeface="+mn-ea"/>
+        <a:cs typeface="+mn-cs"/>
+      </a:defRPr>
+    </a:lvl5pPr>
+    <a:lvl6pPr marL="2286000" algn="l" defTabSz="914400" rtl="0" eaLnBrk="1" latinLnBrk="0" hangingPunct="1">
+      <a:defRPr sz="1200" kern="1200">
+        <a:solidFill>
+          <a:schemeClr val="tx1"/>
+        </a:solidFill>
+        <a:latin typeface="+mn-lt"/>
+        <a:ea typeface="+mn-ea"/>
+        <a:cs typeface="+mn-cs"/>
+      </a:defRPr>
+    </a:lvl6pPr>
+    <a:lvl7pPr marL="2743200" algn="l" defTabSz="914400" rtl="0" eaLnBrk="1" latinLnBrk="0" hangingPunct="1">
+      <a:defRPr sz="1200" kern="1200">
+        <a:solidFill>
+          <a:schemeClr val="tx1"/>
+        </a:solidFill>
+        <a:latin typeface="+mn-lt"/>
+        <a:ea typeface="+mn-ea"/>
+        <a:cs typeface="+mn-cs"/>
+      </a:defRPr>
+    </a:lvl7pPr>
+    <a:lvl8pPr marL="3200400" algn="l" defTabSz="914400" rtl="0" eaLnBrk="1" latinLnBrk="0" hangingPunct="1">
+      <a:defRPr sz="1200" kern="1200">
+        <a:solidFill>
+          <a:schemeClr val="tx1"/>
+        </a:solidFill>
+        <a:latin typeface="+mn-lt"/>
+        <a:ea typeface="+mn-ea"/>
+        <a:cs typeface="+mn-cs"/>
+      </a:defRPr>
+    </a:lvl8pPr>
+    <a:lvl9pPr marL="3657600" algn="l" defTabSz="914400" rtl="0" eaLnBrk="1" latinLnBrk="0" hangingPunct="1">
+      <a:defRPr sz="1200" kern="1200">
+        <a:solidFill>
+          <a:schemeClr val="tx1"/>
+        </a:solidFill>
+        <a:latin typeface="+mn-lt"/>
+        <a:ea typeface="+mn-ea"/>
+        <a:cs typeface="+mn-cs"/>
+      </a:defRPr>
+    </a:lvl9pPr>
+  </p:notesStyle>
+</p:notesMaster>
+</file>
+
+<file path=ppt/notesSlides/notesSlide1.xml><?xml version="1.0" encoding="utf-8"?>
+<p:notes xmlns:a="http://schemas.openxmlformats.org/drawingml/2006/main" xmlns:r="http://schemas.openxmlformats.org/officeDocument/2006/relationships" xmlns:p="http://schemas.openxmlformats.org/presentationml/2006/main">
+  <p:cSld>
+    <p:spTree>
+      <p:nvGrpSpPr>
+        <p:cNvPr id="1" name=""/>
+        <p:cNvGrpSpPr/>
+        <p:nvPr/>
+      </p:nvGrpSpPr>
+      <p:grpSpPr>
+        <a:xfrm>
+          <a:off x="0" y="0"/>
+          <a:ext cx="0" cy="0"/>
+          <a:chOff x="0" y="0"/>
+          <a:chExt cx="0" cy="0"/>
+        </a:xfrm>
+      </p:grpSpPr>
+      <p:sp>
+        <p:nvSpPr>
+          <p:cNvPr id="2" name="Slide Image Placeholder 1"/>
+          <p:cNvSpPr>
+            <a:spLocks noGrp="1" noRot="1" noChangeAspect="1"/>
+          </p:cNvSpPr>
+          <p:nvPr>
+            <p:ph type="sldImg"/>
+          </p:nvPr>
+        </p:nvSpPr>
+        <p:spPr/>
+      </p:sp>
+      <p:sp>
+        <p:nvSpPr>
+          <p:cNvPr id="3" name="Notes Placeholder 2"/>
+          <p:cNvSpPr>
+            <a:spLocks noGrp="1"/>
+          </p:cNvSpPr>
+          <p:nvPr>
+            <p:ph type="body" idx="1"/>
+          </p:nvPr>
+        </p:nvSpPr>
+        <p:spPr/>
+        <p:txBody>
+          <a:bodyPr/>
+          <a:lstStyle/>
+          <a:p>
+            <a:endParaRPr lang="en-US" dirty="0"/>
+          </a:p>
+        </p:txBody>
+      </p:sp>
+      <p:sp>
+        <p:nvSpPr>
+          <p:cNvPr id="4" name="Slide Number Placeholder 3"/>
+          <p:cNvSpPr>
+            <a:spLocks noGrp="1"/>
+          </p:cNvSpPr>
+          <p:nvPr>
+            <p:ph type="sldNum" sz="quarter" idx="5"/>
+          </p:nvPr>
+        </p:nvSpPr>
+        <p:spPr/>
+        <p:txBody>
+          <a:bodyPr/>
+          <a:lstStyle/>
+          <a:p>
+            <a:fld id="{1E3DBBED-931B-4EE7-9616-2DA9C22A96FE}" type="slidenum">
+              <a:rPr lang="en-US" smtClean="0"/>
+              <a:t>29</a:t>
+            </a:fld>
+            <a:endParaRPr lang="en-US"/>
+          </a:p>
+        </p:txBody>
+      </p:sp>
+    </p:spTree>
+    <p:extLst>
+      <p:ext uri="{BB962C8B-B14F-4D97-AF65-F5344CB8AC3E}">
+        <p14:creationId xmlns:p14="http://schemas.microsoft.com/office/powerpoint/2010/main" val="3869714748"/>
+      </p:ext>
+    </p:extLst>
+  </p:cSld>
+  <p:clrMapOvr>
+    <a:masterClrMapping/>
+  </p:clrMapOvr>
+</p:notes>
 </file>
 
 <file path=ppt/slideLayouts/slideLayout1.xml><?xml version="1.0" encoding="utf-8"?>
@@ -268,7 +709,7 @@
           <a:p>
             <a:fld id="{210303FB-695A-4F0B-A3A5-34DCA9D692CF}" type="datetimeFigureOut">
               <a:rPr lang="en-US" smtClean="0"/>
-              <a:t>3/21/2026</a:t>
+              <a:t>3/23/2026</a:t>
             </a:fld>
             <a:endParaRPr lang="en-US"/>
           </a:p>
@@ -438,7 +879,7 @@
           <a:p>
             <a:fld id="{210303FB-695A-4F0B-A3A5-34DCA9D692CF}" type="datetimeFigureOut">
               <a:rPr lang="en-US" smtClean="0"/>
-              <a:t>3/21/2026</a:t>
+              <a:t>3/23/2026</a:t>
             </a:fld>
             <a:endParaRPr lang="en-US"/>
           </a:p>
@@ -618,7 +1059,7 @@
           <a:p>
             <a:fld id="{210303FB-695A-4F0B-A3A5-34DCA9D692CF}" type="datetimeFigureOut">
               <a:rPr lang="en-US" smtClean="0"/>
-              <a:t>3/21/2026</a:t>
+              <a:t>3/23/2026</a:t>
             </a:fld>
             <a:endParaRPr lang="en-US"/>
           </a:p>
@@ -788,7 +1229,7 @@
           <a:p>
             <a:fld id="{210303FB-695A-4F0B-A3A5-34DCA9D692CF}" type="datetimeFigureOut">
               <a:rPr lang="en-US" smtClean="0"/>
-              <a:t>3/21/2026</a:t>
+              <a:t>3/23/2026</a:t>
             </a:fld>
             <a:endParaRPr lang="en-US"/>
           </a:p>
@@ -1034,7 +1475,7 @@
           <a:p>
             <a:fld id="{210303FB-695A-4F0B-A3A5-34DCA9D692CF}" type="datetimeFigureOut">
               <a:rPr lang="en-US" smtClean="0"/>
-              <a:t>3/21/2026</a:t>
+              <a:t>3/23/2026</a:t>
             </a:fld>
             <a:endParaRPr lang="en-US"/>
           </a:p>
@@ -1266,7 +1707,7 @@
           <a:p>
             <a:fld id="{210303FB-695A-4F0B-A3A5-34DCA9D692CF}" type="datetimeFigureOut">
               <a:rPr lang="en-US" smtClean="0"/>
-              <a:t>3/21/2026</a:t>
+              <a:t>3/23/2026</a:t>
             </a:fld>
             <a:endParaRPr lang="en-US"/>
           </a:p>
@@ -1633,7 +2074,7 @@
           <a:p>
             <a:fld id="{210303FB-695A-4F0B-A3A5-34DCA9D692CF}" type="datetimeFigureOut">
               <a:rPr lang="en-US" smtClean="0"/>
-              <a:t>3/21/2026</a:t>
+              <a:t>3/23/2026</a:t>
             </a:fld>
             <a:endParaRPr lang="en-US"/>
           </a:p>
@@ -1751,7 +2192,7 @@
           <a:p>
             <a:fld id="{210303FB-695A-4F0B-A3A5-34DCA9D692CF}" type="datetimeFigureOut">
               <a:rPr lang="en-US" smtClean="0"/>
-              <a:t>3/21/2026</a:t>
+              <a:t>3/23/2026</a:t>
             </a:fld>
             <a:endParaRPr lang="en-US"/>
           </a:p>
@@ -1846,7 +2287,7 @@
           <a:p>
             <a:fld id="{210303FB-695A-4F0B-A3A5-34DCA9D692CF}" type="datetimeFigureOut">
               <a:rPr lang="en-US" smtClean="0"/>
-              <a:t>3/21/2026</a:t>
+              <a:t>3/23/2026</a:t>
             </a:fld>
             <a:endParaRPr lang="en-US"/>
           </a:p>
@@ -2123,7 +2564,7 @@
           <a:p>
             <a:fld id="{210303FB-695A-4F0B-A3A5-34DCA9D692CF}" type="datetimeFigureOut">
               <a:rPr lang="en-US" smtClean="0"/>
-              <a:t>3/21/2026</a:t>
+              <a:t>3/23/2026</a:t>
             </a:fld>
             <a:endParaRPr lang="en-US"/>
           </a:p>
@@ -2380,7 +2821,7 @@
           <a:p>
             <a:fld id="{210303FB-695A-4F0B-A3A5-34DCA9D692CF}" type="datetimeFigureOut">
               <a:rPr lang="en-US" smtClean="0"/>
-              <a:t>3/21/2026</a:t>
+              <a:t>3/23/2026</a:t>
             </a:fld>
             <a:endParaRPr lang="en-US"/>
           </a:p>
@@ -2593,7 +3034,7 @@
           <a:p>
             <a:fld id="{210303FB-695A-4F0B-A3A5-34DCA9D692CF}" type="datetimeFigureOut">
               <a:rPr lang="en-US" smtClean="0"/>
-              <a:t>3/21/2026</a:t>
+              <a:t>3/23/2026</a:t>
             </a:fld>
             <a:endParaRPr lang="en-US"/>
           </a:p>
@@ -3345,8 +3786,8 @@
         </p:blipFill>
         <p:spPr>
           <a:xfrm>
-            <a:off x="3446871" y="749741"/>
-            <a:ext cx="8440328" cy="3591426"/>
+            <a:off x="3456652" y="749742"/>
+            <a:ext cx="8387065" cy="3568762"/>
           </a:xfrm>
           <a:prstGeom prst="rect">
             <a:avLst/>
@@ -7941,7 +8382,7 @@
           <a:p>
             <a:r>
               <a:rPr lang="en-US" dirty="0"/>
-              <a:t>Other signals functions</a:t>
+              <a:t>Other signals features</a:t>
             </a:r>
           </a:p>
         </p:txBody>
@@ -7965,7 +8406,7 @@
         <p:spPr/>
         <p:txBody>
           <a:bodyPr>
-            <a:normAutofit lnSpcReduction="10000"/>
+            <a:normAutofit fontScale="85000" lnSpcReduction="20000"/>
           </a:bodyPr>
           <a:lstStyle/>
           <a:p>
@@ -7993,6 +8434,37 @@
               <a:rPr lang="en-US" dirty="0"/>
               <a:t>output</a:t>
             </a:r>
+          </a:p>
+          <a:p>
+            <a:r>
+              <a:rPr lang="en-US" dirty="0" err="1"/>
+              <a:t>viewChild</a:t>
+            </a:r>
+            <a:r>
+              <a:rPr lang="en-US" dirty="0"/>
+              <a:t>, </a:t>
+            </a:r>
+            <a:r>
+              <a:rPr lang="en-US" dirty="0" err="1"/>
+              <a:t>viewChildren</a:t>
+            </a:r>
+            <a:r>
+              <a:rPr lang="en-US" dirty="0"/>
+              <a:t>, </a:t>
+            </a:r>
+            <a:r>
+              <a:rPr lang="en-US" dirty="0" err="1"/>
+              <a:t>contentChild</a:t>
+            </a:r>
+            <a:r>
+              <a:rPr lang="en-US" dirty="0"/>
+              <a:t>, </a:t>
+            </a:r>
+            <a:r>
+              <a:rPr lang="en-US" dirty="0" err="1"/>
+              <a:t>contentChildren</a:t>
+            </a:r>
+            <a:endParaRPr lang="en-US" dirty="0"/>
           </a:p>
           <a:p>
             <a:r>
@@ -8067,10 +8539,64 @@
             </a:r>
           </a:p>
           <a:p>
+            <a:r>
+              <a:rPr lang="en-US" dirty="0" err="1"/>
+              <a:t>Devtools</a:t>
+            </a:r>
             <a:endParaRPr lang="en-US" dirty="0"/>
           </a:p>
-        </p:txBody>
-      </p:sp>
+          <a:p>
+            <a:endParaRPr lang="en-US" dirty="0"/>
+          </a:p>
+        </p:txBody>
+      </p:sp>
+      <p:pic>
+        <p:nvPicPr>
+          <p:cNvPr id="1026" name="Picture 2" descr="Stream Sich Ft. Sejmi- Impostor (m/m prod.sejmi) by s i c h | Listen online  for free on SoundCloud">
+            <a:extLst>
+              <a:ext uri="{FF2B5EF4-FFF2-40B4-BE49-F238E27FC236}">
+                <a16:creationId xmlns:a16="http://schemas.microsoft.com/office/drawing/2014/main" id="{ABF22791-3231-C993-0960-D522A390D1D0}"/>
+              </a:ext>
+            </a:extLst>
+          </p:cNvPr>
+          <p:cNvPicPr>
+            <a:picLocks noChangeAspect="1" noChangeArrowheads="1"/>
+          </p:cNvPicPr>
+          <p:nvPr/>
+        </p:nvPicPr>
+        <p:blipFill>
+          <a:blip r:embed="rId3">
+            <a:extLst>
+              <a:ext uri="{28A0092B-C50C-407E-A947-70E740481C1C}">
+                <a14:useLocalDpi xmlns:a14="http://schemas.microsoft.com/office/drawing/2010/main" val="0"/>
+              </a:ext>
+            </a:extLst>
+          </a:blip>
+          <a:srcRect/>
+          <a:stretch>
+            <a:fillRect/>
+          </a:stretch>
+        </p:blipFill>
+        <p:spPr bwMode="auto">
+          <a:xfrm>
+            <a:off x="2129142" y="2876550"/>
+            <a:ext cx="458416" cy="458416"/>
+          </a:xfrm>
+          <a:prstGeom prst="rect">
+            <a:avLst/>
+          </a:prstGeom>
+          <a:noFill/>
+          <a:extLst>
+            <a:ext uri="{909E8E84-426E-40DD-AFC4-6F175D3DCCD1}">
+              <a14:hiddenFill xmlns:a14="http://schemas.microsoft.com/office/drawing/2010/main">
+                <a:solidFill>
+                  <a:srgbClr val="FFFFFF"/>
+                </a:solidFill>
+              </a14:hiddenFill>
+            </a:ext>
+          </a:extLst>
+        </p:spPr>
+      </p:pic>
     </p:spTree>
     <p:extLst>
       <p:ext uri="{BB962C8B-B14F-4D97-AF65-F5344CB8AC3E}">
@@ -8298,7 +8824,7 @@
                             </p:stCondLst>
                             <p:childTnLst>
                               <p:par>
-                                <p:cTn id="21" presetID="1" presetClass="entr" presetSubtype="0" fill="hold" grpId="0" nodeType="clickEffect">
+                                <p:cTn id="21" presetID="42" presetClass="entr" presetSubtype="0" fill="hold" nodeType="clickEffect">
                                   <p:stCondLst>
                                     <p:cond delay="0"/>
                                   </p:stCondLst>
@@ -8306,6 +8832,105 @@
                                     <p:set>
                                       <p:cBhvr>
                                         <p:cTn id="22" dur="1" fill="hold">
+                                          <p:stCondLst>
+                                            <p:cond delay="0"/>
+                                          </p:stCondLst>
+                                        </p:cTn>
+                                        <p:tgtEl>
+                                          <p:spTgt spid="1026"/>
+                                        </p:tgtEl>
+                                        <p:attrNameLst>
+                                          <p:attrName>style.visibility</p:attrName>
+                                        </p:attrNameLst>
+                                      </p:cBhvr>
+                                      <p:to>
+                                        <p:strVal val="visible"/>
+                                      </p:to>
+                                    </p:set>
+                                    <p:animEffect transition="in" filter="fade">
+                                      <p:cBhvr>
+                                        <p:cTn id="23" dur="1000"/>
+                                        <p:tgtEl>
+                                          <p:spTgt spid="1026"/>
+                                        </p:tgtEl>
+                                      </p:cBhvr>
+                                    </p:animEffect>
+                                    <p:anim calcmode="lin" valueType="num">
+                                      <p:cBhvr>
+                                        <p:cTn id="24" dur="1000" fill="hold"/>
+                                        <p:tgtEl>
+                                          <p:spTgt spid="1026"/>
+                                        </p:tgtEl>
+                                        <p:attrNameLst>
+                                          <p:attrName>ppt_x</p:attrName>
+                                        </p:attrNameLst>
+                                      </p:cBhvr>
+                                      <p:tavLst>
+                                        <p:tav tm="0">
+                                          <p:val>
+                                            <p:strVal val="#ppt_x"/>
+                                          </p:val>
+                                        </p:tav>
+                                        <p:tav tm="100000">
+                                          <p:val>
+                                            <p:strVal val="#ppt_x"/>
+                                          </p:val>
+                                        </p:tav>
+                                      </p:tavLst>
+                                    </p:anim>
+                                    <p:anim calcmode="lin" valueType="num">
+                                      <p:cBhvr>
+                                        <p:cTn id="25" dur="1000" fill="hold"/>
+                                        <p:tgtEl>
+                                          <p:spTgt spid="1026"/>
+                                        </p:tgtEl>
+                                        <p:attrNameLst>
+                                          <p:attrName>ppt_y</p:attrName>
+                                        </p:attrNameLst>
+                                      </p:cBhvr>
+                                      <p:tavLst>
+                                        <p:tav tm="0">
+                                          <p:val>
+                                            <p:strVal val="#ppt_y+.1"/>
+                                          </p:val>
+                                        </p:tav>
+                                        <p:tav tm="100000">
+                                          <p:val>
+                                            <p:strVal val="#ppt_y"/>
+                                          </p:val>
+                                        </p:tav>
+                                      </p:tavLst>
+                                    </p:anim>
+                                  </p:childTnLst>
+                                </p:cTn>
+                              </p:par>
+                            </p:childTnLst>
+                          </p:cTn>
+                        </p:par>
+                      </p:childTnLst>
+                    </p:cTn>
+                  </p:par>
+                  <p:par>
+                    <p:cTn id="26" fill="hold">
+                      <p:stCondLst>
+                        <p:cond delay="indefinite"/>
+                      </p:stCondLst>
+                      <p:childTnLst>
+                        <p:par>
+                          <p:cTn id="27" fill="hold">
+                            <p:stCondLst>
+                              <p:cond delay="0"/>
+                            </p:stCondLst>
+                            <p:childTnLst>
+                              <p:par>
+                                <p:cTn id="28" presetID="1" presetClass="entr" presetSubtype="0" fill="hold" grpId="0" nodeType="clickEffect">
+                                  <p:stCondLst>
+                                    <p:cond delay="0"/>
+                                  </p:stCondLst>
+                                  <p:childTnLst>
+                                    <p:set>
+                                      <p:cBhvr>
+                                        <p:cTn id="29" dur="1" fill="hold">
                                           <p:stCondLst>
                                             <p:cond delay="0"/>
                                           </p:stCondLst>
@@ -8335,26 +8960,26 @@
                     </p:cTn>
                   </p:par>
                   <p:par>
-                    <p:cTn id="23" fill="hold">
+                    <p:cTn id="30" fill="hold">
                       <p:stCondLst>
                         <p:cond delay="indefinite"/>
                       </p:stCondLst>
                       <p:childTnLst>
                         <p:par>
-                          <p:cTn id="24" fill="hold">
+                          <p:cTn id="31" fill="hold">
                             <p:stCondLst>
                               <p:cond delay="0"/>
                             </p:stCondLst>
                             <p:childTnLst>
                               <p:par>
-                                <p:cTn id="25" presetID="1" presetClass="entr" presetSubtype="0" fill="hold" grpId="0" nodeType="clickEffect">
+                                <p:cTn id="32" presetID="1" presetClass="entr" presetSubtype="0" fill="hold" grpId="0" nodeType="clickEffect">
                                   <p:stCondLst>
                                     <p:cond delay="0"/>
                                   </p:stCondLst>
                                   <p:childTnLst>
                                     <p:set>
                                       <p:cBhvr>
-                                        <p:cTn id="26" dur="1" fill="hold">
+                                        <p:cTn id="33" dur="1" fill="hold">
                                           <p:stCondLst>
                                             <p:cond delay="0"/>
                                           </p:stCondLst>
@@ -8384,26 +9009,26 @@
                     </p:cTn>
                   </p:par>
                   <p:par>
-                    <p:cTn id="27" fill="hold">
+                    <p:cTn id="34" fill="hold">
                       <p:stCondLst>
                         <p:cond delay="indefinite"/>
                       </p:stCondLst>
                       <p:childTnLst>
                         <p:par>
-                          <p:cTn id="28" fill="hold">
+                          <p:cTn id="35" fill="hold">
                             <p:stCondLst>
                               <p:cond delay="0"/>
                             </p:stCondLst>
                             <p:childTnLst>
                               <p:par>
-                                <p:cTn id="29" presetID="1" presetClass="entr" presetSubtype="0" fill="hold" grpId="0" nodeType="clickEffect">
+                                <p:cTn id="36" presetID="1" presetClass="entr" presetSubtype="0" fill="hold" grpId="0" nodeType="clickEffect">
                                   <p:stCondLst>
                                     <p:cond delay="0"/>
                                   </p:stCondLst>
                                   <p:childTnLst>
                                     <p:set>
                                       <p:cBhvr>
-                                        <p:cTn id="30" dur="1" fill="hold">
+                                        <p:cTn id="37" dur="1" fill="hold">
                                           <p:stCondLst>
                                             <p:cond delay="0"/>
                                           </p:stCondLst>
@@ -8433,26 +9058,26 @@
                     </p:cTn>
                   </p:par>
                   <p:par>
-                    <p:cTn id="31" fill="hold">
+                    <p:cTn id="38" fill="hold">
                       <p:stCondLst>
                         <p:cond delay="indefinite"/>
                       </p:stCondLst>
                       <p:childTnLst>
                         <p:par>
-                          <p:cTn id="32" fill="hold">
+                          <p:cTn id="39" fill="hold">
                             <p:stCondLst>
                               <p:cond delay="0"/>
                             </p:stCondLst>
                             <p:childTnLst>
                               <p:par>
-                                <p:cTn id="33" presetID="1" presetClass="entr" presetSubtype="0" fill="hold" grpId="0" nodeType="clickEffect">
+                                <p:cTn id="40" presetID="1" presetClass="entr" presetSubtype="0" fill="hold" grpId="0" nodeType="clickEffect">
                                   <p:stCondLst>
                                     <p:cond delay="0"/>
                                   </p:stCondLst>
                                   <p:childTnLst>
                                     <p:set>
                                       <p:cBhvr>
-                                        <p:cTn id="34" dur="1" fill="hold">
+                                        <p:cTn id="41" dur="1" fill="hold">
                                           <p:stCondLst>
                                             <p:cond delay="0"/>
                                           </p:stCondLst>
@@ -8482,26 +9107,26 @@
                     </p:cTn>
                   </p:par>
                   <p:par>
-                    <p:cTn id="35" fill="hold">
+                    <p:cTn id="42" fill="hold">
                       <p:stCondLst>
                         <p:cond delay="indefinite"/>
                       </p:stCondLst>
                       <p:childTnLst>
                         <p:par>
-                          <p:cTn id="36" fill="hold">
+                          <p:cTn id="43" fill="hold">
                             <p:stCondLst>
                               <p:cond delay="0"/>
                             </p:stCondLst>
                             <p:childTnLst>
                               <p:par>
-                                <p:cTn id="37" presetID="1" presetClass="entr" presetSubtype="0" fill="hold" grpId="0" nodeType="clickEffect">
+                                <p:cTn id="44" presetID="1" presetClass="entr" presetSubtype="0" fill="hold" grpId="0" nodeType="clickEffect">
                                   <p:stCondLst>
                                     <p:cond delay="0"/>
                                   </p:stCondLst>
                                   <p:childTnLst>
                                     <p:set>
                                       <p:cBhvr>
-                                        <p:cTn id="38" dur="1" fill="hold">
+                                        <p:cTn id="45" dur="1" fill="hold">
                                           <p:stCondLst>
                                             <p:cond delay="0"/>
                                           </p:stCondLst>
@@ -8510,6 +9135,104 @@
                                           <p:spTgt spid="8">
                                             <p:txEl>
                                               <p:pRg st="8" end="8"/>
+                                            </p:txEl>
+                                          </p:spTgt>
+                                        </p:tgtEl>
+                                        <p:attrNameLst>
+                                          <p:attrName>style.visibility</p:attrName>
+                                        </p:attrNameLst>
+                                      </p:cBhvr>
+                                      <p:to>
+                                        <p:strVal val="visible"/>
+                                      </p:to>
+                                    </p:set>
+                                  </p:childTnLst>
+                                </p:cTn>
+                              </p:par>
+                            </p:childTnLst>
+                          </p:cTn>
+                        </p:par>
+                      </p:childTnLst>
+                    </p:cTn>
+                  </p:par>
+                  <p:par>
+                    <p:cTn id="46" fill="hold">
+                      <p:stCondLst>
+                        <p:cond delay="indefinite"/>
+                      </p:stCondLst>
+                      <p:childTnLst>
+                        <p:par>
+                          <p:cTn id="47" fill="hold">
+                            <p:stCondLst>
+                              <p:cond delay="0"/>
+                            </p:stCondLst>
+                            <p:childTnLst>
+                              <p:par>
+                                <p:cTn id="48" presetID="1" presetClass="entr" presetSubtype="0" fill="hold" grpId="0" nodeType="clickEffect">
+                                  <p:stCondLst>
+                                    <p:cond delay="0"/>
+                                  </p:stCondLst>
+                                  <p:childTnLst>
+                                    <p:set>
+                                      <p:cBhvr>
+                                        <p:cTn id="49" dur="1" fill="hold">
+                                          <p:stCondLst>
+                                            <p:cond delay="0"/>
+                                          </p:stCondLst>
+                                        </p:cTn>
+                                        <p:tgtEl>
+                                          <p:spTgt spid="8">
+                                            <p:txEl>
+                                              <p:pRg st="9" end="9"/>
+                                            </p:txEl>
+                                          </p:spTgt>
+                                        </p:tgtEl>
+                                        <p:attrNameLst>
+                                          <p:attrName>style.visibility</p:attrName>
+                                        </p:attrNameLst>
+                                      </p:cBhvr>
+                                      <p:to>
+                                        <p:strVal val="visible"/>
+                                      </p:to>
+                                    </p:set>
+                                  </p:childTnLst>
+                                </p:cTn>
+                              </p:par>
+                            </p:childTnLst>
+                          </p:cTn>
+                        </p:par>
+                      </p:childTnLst>
+                    </p:cTn>
+                  </p:par>
+                  <p:par>
+                    <p:cTn id="50" fill="hold">
+                      <p:stCondLst>
+                        <p:cond delay="indefinite"/>
+                      </p:stCondLst>
+                      <p:childTnLst>
+                        <p:par>
+                          <p:cTn id="51" fill="hold">
+                            <p:stCondLst>
+                              <p:cond delay="0"/>
+                            </p:stCondLst>
+                            <p:childTnLst>
+                              <p:par>
+                                <p:cTn id="52" presetID="1" presetClass="entr" presetSubtype="0" fill="hold" grpId="0" nodeType="clickEffect">
+                                  <p:stCondLst>
+                                    <p:cond delay="0"/>
+                                  </p:stCondLst>
+                                  <p:childTnLst>
+                                    <p:set>
+                                      <p:cBhvr>
+                                        <p:cTn id="53" dur="1" fill="hold">
+                                          <p:stCondLst>
+                                            <p:cond delay="0"/>
+                                          </p:stCondLst>
+                                        </p:cTn>
+                                        <p:tgtEl>
+                                          <p:spTgt spid="8">
+                                            <p:txEl>
+                                              <p:pRg st="10" end="10"/>
                                             </p:txEl>
                                           </p:spTgt>
                                         </p:tgtEl>
@@ -8552,7 +9275,7 @@
       </p:par>
     </p:tnLst>
     <p:bldLst>
-      <p:bldP spid="8" grpId="0" build="p"/>
+      <p:bldP spid="8" grpId="0" uiExpand="1" build="p"/>
     </p:bldLst>
   </p:timing>
 </p:sld>
@@ -11255,4 +11978,319 @@
     </a:ext>
   </a:extLst>
 </a:theme>
+</file>
+
+<file path=ppt/theme/theme2.xml><?xml version="1.0" encoding="utf-8"?>
+<a:theme xmlns:a="http://schemas.openxmlformats.org/drawingml/2006/main" name="Office Theme">
+  <a:themeElements>
+    <a:clrScheme name="Office">
+      <a:dk1>
+        <a:sysClr val="windowText" lastClr="000000"/>
+      </a:dk1>
+      <a:lt1>
+        <a:sysClr val="window" lastClr="FFFFFF"/>
+      </a:lt1>
+      <a:dk2>
+        <a:srgbClr val="0E2841"/>
+      </a:dk2>
+      <a:lt2>
+        <a:srgbClr val="E8E8E8"/>
+      </a:lt2>
+      <a:accent1>
+        <a:srgbClr val="156082"/>
+      </a:accent1>
+      <a:accent2>
+        <a:srgbClr val="E97132"/>
+      </a:accent2>
+      <a:accent3>
+        <a:srgbClr val="196B24"/>
+      </a:accent3>
+      <a:accent4>
+        <a:srgbClr val="0F9ED5"/>
+      </a:accent4>
+      <a:accent5>
+        <a:srgbClr val="A02B93"/>
+      </a:accent5>
+      <a:accent6>
+        <a:srgbClr val="4EA72E"/>
+      </a:accent6>
+      <a:hlink>
+        <a:srgbClr val="467886"/>
+      </a:hlink>
+      <a:folHlink>
+        <a:srgbClr val="96607D"/>
+      </a:folHlink>
+    </a:clrScheme>
+    <a:fontScheme name="Office">
+      <a:majorFont>
+        <a:latin typeface="Aptos Display" panose="02110004020202020204"/>
+        <a:ea typeface=""/>
+        <a:cs typeface=""/>
+        <a:font script="Jpan" typeface="游ゴシック Light"/>
+        <a:font script="Hang" typeface="맑은 고딕"/>
+        <a:font script="Hans" typeface="等线 Light"/>
+        <a:font script="Hant" typeface="新細明體"/>
+        <a:font script="Arab" typeface="Times New Roman"/>
+        <a:font script="Hebr" typeface="Times New Roman"/>
+        <a:font script="Thai" typeface="Angsana New"/>
+        <a:font script="Ethi" typeface="Nyala"/>
+        <a:font script="Beng" typeface="Vrinda"/>
+        <a:font script="Gujr" typeface="Shruti"/>
+        <a:font script="Khmr" typeface="MoolBoran"/>
+        <a:font script="Knda" typeface="Tunga"/>
+        <a:font script="Guru" typeface="Raavi"/>
+        <a:font script="Cans" typeface="Euphemia"/>
+        <a:font script="Cher" typeface="Plantagenet Cherokee"/>
+        <a:font script="Yiii" typeface="Microsoft Yi Baiti"/>
+        <a:font script="Tibt" typeface="Microsoft Himalaya"/>
+        <a:font script="Thaa" typeface="MV Boli"/>
+        <a:font script="Deva" typeface="Mangal"/>
+        <a:font script="Telu" typeface="Gautami"/>
+        <a:font script="Taml" typeface="Latha"/>
+        <a:font script="Syrc" typeface="Estrangelo Edessa"/>
+        <a:font script="Orya" typeface="Kalinga"/>
+        <a:font script="Mlym" typeface="Kartika"/>
+        <a:font script="Laoo" typeface="DokChampa"/>
+        <a:font script="Sinh" typeface="Iskoola Pota"/>
+        <a:font script="Mong" typeface="Mongolian Baiti"/>
+        <a:font script="Viet" typeface="Times New Roman"/>
+        <a:font script="Uigh" typeface="Microsoft Uighur"/>
+        <a:font script="Geor" typeface="Sylfaen"/>
+        <a:font script="Armn" typeface="Arial"/>
+        <a:font script="Bugi" typeface="Leelawadee UI"/>
+        <a:font script="Bopo" typeface="Microsoft JhengHei"/>
+        <a:font script="Java" typeface="Javanese Text"/>
+        <a:font script="Lisu" typeface="Segoe UI"/>
+        <a:font script="Mymr" typeface="Myanmar Text"/>
+        <a:font script="Nkoo" typeface="Ebrima"/>
+        <a:font script="Olck" typeface="Nirmala UI"/>
+        <a:font script="Osma" typeface="Ebrima"/>
+        <a:font script="Phag" typeface="Phagspa"/>
+        <a:font script="Syrn" typeface="Estrangelo Edessa"/>
+        <a:font script="Syrj" typeface="Estrangelo Edessa"/>
+        <a:font script="Syre" typeface="Estrangelo Edessa"/>
+        <a:font script="Sora" typeface="Nirmala UI"/>
+        <a:font script="Tale" typeface="Microsoft Tai Le"/>
+        <a:font script="Talu" typeface="Microsoft New Tai Lue"/>
+        <a:font script="Tfng" typeface="Ebrima"/>
+      </a:majorFont>
+      <a:minorFont>
+        <a:latin typeface="Aptos" panose="02110004020202020204"/>
+        <a:ea typeface=""/>
+        <a:cs typeface=""/>
+        <a:font script="Jpan" typeface="游ゴシック"/>
+        <a:font script="Hang" typeface="맑은 고딕"/>
+        <a:font script="Hans" typeface="等线"/>
+        <a:font script="Hant" typeface="新細明體"/>
+        <a:font script="Arab" typeface="Arial"/>
+        <a:font script="Hebr" typeface="Arial"/>
+        <a:font script="Thai" typeface="Cordia New"/>
+        <a:font script="Ethi" typeface="Nyala"/>
+        <a:font script="Beng" typeface="Vrinda"/>
+        <a:font script="Gujr" typeface="Shruti"/>
+        <a:font script="Khmr" typeface="DaunPenh"/>
+        <a:font script="Knda" typeface="Tunga"/>
+        <a:font script="Guru" typeface="Raavi"/>
+        <a:font script="Cans" typeface="Euphemia"/>
+        <a:font script="Cher" typeface="Plantagenet Cherokee"/>
+        <a:font script="Yiii" typeface="Microsoft Yi Baiti"/>
+        <a:font script="Tibt" typeface="Microsoft Himalaya"/>
+        <a:font script="Thaa" typeface="MV Boli"/>
+        <a:font script="Deva" typeface="Mangal"/>
+        <a:font script="Telu" typeface="Gautami"/>
+        <a:font script="Taml" typeface="Latha"/>
+        <a:font script="Syrc" typeface="Estrangelo Edessa"/>
+        <a:font script="Orya" typeface="Kalinga"/>
+        <a:font script="Mlym" typeface="Kartika"/>
+        <a:font script="Laoo" typeface="DokChampa"/>
+        <a:font script="Sinh" typeface="Iskoola Pota"/>
+        <a:font script="Mong" typeface="Mongolian Baiti"/>
+        <a:font script="Viet" typeface="Arial"/>
+        <a:font script="Uigh" typeface="Microsoft Uighur"/>
+        <a:font script="Geor" typeface="Sylfaen"/>
+        <a:font script="Armn" typeface="Arial"/>
+        <a:font script="Bugi" typeface="Leelawadee UI"/>
+        <a:font script="Bopo" typeface="Microsoft JhengHei"/>
+        <a:font script="Java" typeface="Javanese Text"/>
+        <a:font script="Lisu" typeface="Segoe UI"/>
+        <a:font script="Mymr" typeface="Myanmar Text"/>
+        <a:font script="Nkoo" typeface="Ebrima"/>
+        <a:font script="Olck" typeface="Nirmala UI"/>
+        <a:font script="Osma" typeface="Ebrima"/>
+        <a:font script="Phag" typeface="Phagspa"/>
+        <a:font script="Syrn" typeface="Estrangelo Edessa"/>
+        <a:font script="Syrj" typeface="Estrangelo Edessa"/>
+        <a:font script="Syre" typeface="Estrangelo Edessa"/>
+        <a:font script="Sora" typeface="Nirmala UI"/>
+        <a:font script="Tale" typeface="Microsoft Tai Le"/>
+        <a:font script="Talu" typeface="Microsoft New Tai Lue"/>
+        <a:font script="Tfng" typeface="Ebrima"/>
+      </a:minorFont>
+    </a:fontScheme>
+    <a:fmtScheme name="Office">
+      <a:fillStyleLst>
+        <a:solidFill>
+          <a:schemeClr val="phClr"/>
+        </a:solidFill>
+        <a:gradFill rotWithShape="1">
+          <a:gsLst>
+            <a:gs pos="0">
+              <a:schemeClr val="phClr">
+                <a:lumMod val="110000"/>
+                <a:satMod val="105000"/>
+                <a:tint val="67000"/>
+              </a:schemeClr>
+            </a:gs>
+            <a:gs pos="50000">
+              <a:schemeClr val="phClr">
+                <a:lumMod val="105000"/>
+                <a:satMod val="103000"/>
+                <a:tint val="73000"/>
+              </a:schemeClr>
+            </a:gs>
+            <a:gs pos="100000">
+              <a:schemeClr val="phClr">
+                <a:lumMod val="105000"/>
+                <a:satMod val="109000"/>
+                <a:tint val="81000"/>
+              </a:schemeClr>
+            </a:gs>
+          </a:gsLst>
+          <a:lin ang="5400000" scaled="0"/>
+        </a:gradFill>
+        <a:gradFill rotWithShape="1">
+          <a:gsLst>
+            <a:gs pos="0">
+              <a:schemeClr val="phClr">
+                <a:satMod val="103000"/>
+                <a:lumMod val="102000"/>
+                <a:tint val="94000"/>
+              </a:schemeClr>
+            </a:gs>
+            <a:gs pos="50000">
+              <a:schemeClr val="phClr">
+                <a:satMod val="110000"/>
+                <a:lumMod val="100000"/>
+                <a:shade val="100000"/>
+              </a:schemeClr>
+            </a:gs>
+            <a:gs pos="100000">
+              <a:schemeClr val="phClr">
+                <a:lumMod val="99000"/>
+                <a:satMod val="120000"/>
+                <a:shade val="78000"/>
+              </a:schemeClr>
+            </a:gs>
+          </a:gsLst>
+          <a:lin ang="5400000" scaled="0"/>
+        </a:gradFill>
+      </a:fillStyleLst>
+      <a:lnStyleLst>
+        <a:ln w="12700" cap="flat" cmpd="sng" algn="ctr">
+          <a:solidFill>
+            <a:schemeClr val="phClr"/>
+          </a:solidFill>
+          <a:prstDash val="solid"/>
+          <a:miter lim="800000"/>
+        </a:ln>
+        <a:ln w="19050" cap="flat" cmpd="sng" algn="ctr">
+          <a:solidFill>
+            <a:schemeClr val="phClr"/>
+          </a:solidFill>
+          <a:prstDash val="solid"/>
+          <a:miter lim="800000"/>
+        </a:ln>
+        <a:ln w="25400" cap="flat" cmpd="sng" algn="ctr">
+          <a:solidFill>
+            <a:schemeClr val="phClr"/>
+          </a:solidFill>
+          <a:prstDash val="solid"/>
+          <a:miter lim="800000"/>
+        </a:ln>
+      </a:lnStyleLst>
+      <a:effectStyleLst>
+        <a:effectStyle>
+          <a:effectLst/>
+        </a:effectStyle>
+        <a:effectStyle>
+          <a:effectLst/>
+        </a:effectStyle>
+        <a:effectStyle>
+          <a:effectLst>
+            <a:outerShdw blurRad="57150" dist="19050" dir="5400000" algn="ctr" rotWithShape="0">
+              <a:srgbClr val="000000">
+                <a:alpha val="63000"/>
+              </a:srgbClr>
+            </a:outerShdw>
+          </a:effectLst>
+        </a:effectStyle>
+      </a:effectStyleLst>
+      <a:bgFillStyleLst>
+        <a:solidFill>
+          <a:schemeClr val="phClr"/>
+        </a:solidFill>
+        <a:solidFill>
+          <a:schemeClr val="phClr">
+            <a:tint val="95000"/>
+            <a:satMod val="170000"/>
+          </a:schemeClr>
+        </a:solidFill>
+        <a:gradFill rotWithShape="1">
+          <a:gsLst>
+            <a:gs pos="0">
+              <a:schemeClr val="phClr">
+                <a:tint val="93000"/>
+                <a:satMod val="150000"/>
+                <a:shade val="98000"/>
+                <a:lumMod val="102000"/>
+              </a:schemeClr>
+            </a:gs>
+            <a:gs pos="50000">
+              <a:schemeClr val="phClr">
+                <a:tint val="98000"/>
+                <a:satMod val="130000"/>
+                <a:shade val="90000"/>
+                <a:lumMod val="103000"/>
+              </a:schemeClr>
+            </a:gs>
+            <a:gs pos="100000">
+              <a:schemeClr val="phClr">
+                <a:shade val="63000"/>
+                <a:satMod val="120000"/>
+              </a:schemeClr>
+            </a:gs>
+          </a:gsLst>
+          <a:lin ang="5400000" scaled="0"/>
+        </a:gradFill>
+      </a:bgFillStyleLst>
+    </a:fmtScheme>
+  </a:themeElements>
+  <a:objectDefaults>
+    <a:lnDef>
+      <a:spPr/>
+      <a:bodyPr/>
+      <a:lstStyle/>
+      <a:style>
+        <a:lnRef idx="2">
+          <a:schemeClr val="accent1"/>
+        </a:lnRef>
+        <a:fillRef idx="0">
+          <a:schemeClr val="accent1"/>
+        </a:fillRef>
+        <a:effectRef idx="1">
+          <a:schemeClr val="accent1"/>
+        </a:effectRef>
+        <a:fontRef idx="minor">
+          <a:schemeClr val="tx1"/>
+        </a:fontRef>
+      </a:style>
+    </a:lnDef>
+  </a:objectDefaults>
+  <a:extraClrSchemeLst/>
+  <a:extLst>
+    <a:ext uri="{05A4C25C-085E-4340-85A3-A5531E510DB2}">
+      <thm15:themeFamily xmlns:thm15="http://schemas.microsoft.com/office/thememl/2012/main" name="Office Theme" id="{2E142A2C-CD16-42D6-873A-C26D2A0506FA}" vid="{1BDDFF52-6CD6-40A5-AB3C-68EB2F1E4D0A}"/>
+    </a:ext>
+  </a:extLst>
+</a:theme>
 </file>
</xml_diff>